<commit_message>
Please provide the file changes to generate a commit message.
</commit_message>
<xml_diff>
--- a/programing/Tuần 2 Thiết kế ERD & Kết nối MySQL với Spring Data JPA/[SmartFashion ERP] Tập 4 Thiết kế ERD & Kết nối MySQL với Spring Data JPA (Tuần 2).pptx
+++ b/programing/Tuần 2 Thiết kế ERD & Kết nối MySQL với Spring Data JPA/[SmartFashion ERP] Tập 4 Thiết kế ERD & Kết nối MySQL với Spring Data JPA (Tuần 2).pptx
@@ -8,9 +8,10 @@
     <p:sldId id="256" r:id="rId2"/>
     <p:sldId id="257" r:id="rId3"/>
     <p:sldId id="259" r:id="rId4"/>
-    <p:sldId id="258" r:id="rId5"/>
-    <p:sldId id="260" r:id="rId6"/>
-    <p:sldId id="261" r:id="rId7"/>
+    <p:sldId id="262" r:id="rId5"/>
+    <p:sldId id="258" r:id="rId6"/>
+    <p:sldId id="260" r:id="rId7"/>
+    <p:sldId id="261" r:id="rId8"/>
   </p:sldIdLst>
   <p:sldSz cx="12192000" cy="6858000"/>
   <p:notesSz cx="6858000" cy="9144000"/>
@@ -7177,7 +7178,7 @@
           <a:p>
             <a:fld id="{CE4C4EB9-1BFB-4116-9DD4-EC9D72B8C2EB}" type="datetimeFigureOut">
               <a:rPr lang="en-US" smtClean="0"/>
-              <a:t>1/26/2026</a:t>
+              <a:t>1/28/2026</a:t>
             </a:fld>
             <a:endParaRPr lang="en-US"/>
           </a:p>
@@ -8648,7 +8649,7 @@
           <a:p>
             <a:fld id="{CE4C4EB9-1BFB-4116-9DD4-EC9D72B8C2EB}" type="datetimeFigureOut">
               <a:rPr lang="en-US" smtClean="0"/>
-              <a:t>1/26/2026</a:t>
+              <a:t>1/28/2026</a:t>
             </a:fld>
             <a:endParaRPr lang="en-US"/>
           </a:p>
@@ -10113,7 +10114,7 @@
           <a:p>
             <a:fld id="{CE4C4EB9-1BFB-4116-9DD4-EC9D72B8C2EB}" type="datetimeFigureOut">
               <a:rPr lang="en-US" smtClean="0"/>
-              <a:t>1/26/2026</a:t>
+              <a:t>1/28/2026</a:t>
             </a:fld>
             <a:endParaRPr lang="en-US"/>
           </a:p>
@@ -11580,7 +11581,7 @@
           <a:p>
             <a:fld id="{CE4C4EB9-1BFB-4116-9DD4-EC9D72B8C2EB}" type="datetimeFigureOut">
               <a:rPr lang="en-US" smtClean="0"/>
-              <a:t>1/26/2026</a:t>
+              <a:t>1/28/2026</a:t>
             </a:fld>
             <a:endParaRPr lang="en-US"/>
           </a:p>
@@ -13100,7 +13101,7 @@
           <a:p>
             <a:fld id="{CE4C4EB9-1BFB-4116-9DD4-EC9D72B8C2EB}" type="datetimeFigureOut">
               <a:rPr lang="en-US" smtClean="0"/>
-              <a:t>1/26/2026</a:t>
+              <a:t>1/28/2026</a:t>
             </a:fld>
             <a:endParaRPr lang="en-US"/>
           </a:p>
@@ -14633,7 +14634,7 @@
           <a:p>
             <a:fld id="{CE4C4EB9-1BFB-4116-9DD4-EC9D72B8C2EB}" type="datetimeFigureOut">
               <a:rPr lang="en-US" smtClean="0"/>
-              <a:t>1/26/2026</a:t>
+              <a:t>1/28/2026</a:t>
             </a:fld>
             <a:endParaRPr lang="en-US"/>
           </a:p>
@@ -16310,7 +16311,7 @@
           <a:p>
             <a:fld id="{CE4C4EB9-1BFB-4116-9DD4-EC9D72B8C2EB}" type="datetimeFigureOut">
               <a:rPr lang="en-US" smtClean="0"/>
-              <a:t>1/26/2026</a:t>
+              <a:t>1/28/2026</a:t>
             </a:fld>
             <a:endParaRPr lang="en-US"/>
           </a:p>
@@ -17720,7 +17721,7 @@
           <a:p>
             <a:fld id="{CE4C4EB9-1BFB-4116-9DD4-EC9D72B8C2EB}" type="datetimeFigureOut">
               <a:rPr lang="en-US" smtClean="0"/>
-              <a:t>1/26/2026</a:t>
+              <a:t>1/28/2026</a:t>
             </a:fld>
             <a:endParaRPr lang="en-US"/>
           </a:p>
@@ -17832,7 +17833,7 @@
           <a:p>
             <a:fld id="{CE4C4EB9-1BFB-4116-9DD4-EC9D72B8C2EB}" type="datetimeFigureOut">
               <a:rPr lang="en-US" smtClean="0"/>
-              <a:t>1/26/2026</a:t>
+              <a:t>1/28/2026</a:t>
             </a:fld>
             <a:endParaRPr lang="en-US"/>
           </a:p>
@@ -19370,7 +19371,7 @@
           <a:p>
             <a:fld id="{CE4C4EB9-1BFB-4116-9DD4-EC9D72B8C2EB}" type="datetimeFigureOut">
               <a:rPr lang="en-US" smtClean="0"/>
-              <a:t>1/26/2026</a:t>
+              <a:t>1/28/2026</a:t>
             </a:fld>
             <a:endParaRPr lang="en-US"/>
           </a:p>
@@ -20918,7 +20919,7 @@
           <a:p>
             <a:fld id="{CE4C4EB9-1BFB-4116-9DD4-EC9D72B8C2EB}" type="datetimeFigureOut">
               <a:rPr lang="en-US" smtClean="0"/>
-              <a:t>1/26/2026</a:t>
+              <a:t>1/28/2026</a:t>
             </a:fld>
             <a:endParaRPr lang="en-US"/>
           </a:p>
@@ -21153,7 +21154,7 @@
           <a:p>
             <a:fld id="{CE4C4EB9-1BFB-4116-9DD4-EC9D72B8C2EB}" type="datetimeFigureOut">
               <a:rPr lang="en-US" smtClean="0"/>
-              <a:t>1/26/2026</a:t>
+              <a:t>1/28/2026</a:t>
             </a:fld>
             <a:endParaRPr lang="en-US"/>
           </a:p>
@@ -29669,6 +29670,1771 @@
     <p:bg>
       <p:bgPr>
         <a:solidFill>
+          <a:schemeClr val="bg2"/>
+        </a:solidFill>
+        <a:effectLst/>
+      </p:bgPr>
+    </p:bg>
+    <p:spTree>
+      <p:nvGrpSpPr>
+        <p:cNvPr id="1" name=""/>
+        <p:cNvGrpSpPr/>
+        <p:nvPr/>
+      </p:nvGrpSpPr>
+      <p:grpSpPr>
+        <a:xfrm>
+          <a:off x="0" y="0"/>
+          <a:ext cx="0" cy="0"/>
+          <a:chOff x="0" y="0"/>
+          <a:chExt cx="0" cy="0"/>
+        </a:xfrm>
+      </p:grpSpPr>
+      <p:grpSp>
+        <p:nvGrpSpPr>
+          <p:cNvPr id="35" name="Group 34">
+            <a:extLst>
+              <a:ext uri="{FF2B5EF4-FFF2-40B4-BE49-F238E27FC236}">
+                <a16:creationId xmlns:a16="http://schemas.microsoft.com/office/drawing/2014/main" id="{9EA06921-3C0C-4126-AF75-9499D48390C3}"/>
+              </a:ext>
+              <a:ext uri="{C183D7F6-B498-43B3-948B-1728B52AA6E4}">
+                <adec:decorative xmlns:adec="http://schemas.microsoft.com/office/drawing/2017/decorative" val="1"/>
+              </a:ext>
+            </a:extLst>
+          </p:cNvPr>
+          <p:cNvGrpSpPr>
+            <a:grpSpLocks noGrp="1" noUngrp="1" noRot="1" noChangeAspect="1" noMove="1" noResize="1"/>
+          </p:cNvGrpSpPr>
+          <p:nvPr>
+            <p:extLst>
+              <p:ext uri="{386F3935-93C4-4BCD-93E2-E3B085C9AB24}">
+                <p16:designElem xmlns:p16="http://schemas.microsoft.com/office/powerpoint/2015/main" val="1"/>
+              </p:ext>
+            </p:extLst>
+          </p:nvPr>
+        </p:nvGrpSpPr>
+        <p:grpSpPr>
+          <a:xfrm>
+            <a:off x="-417513" y="0"/>
+            <a:ext cx="12584114" cy="6853238"/>
+            <a:chOff x="-417513" y="0"/>
+            <a:chExt cx="12584114" cy="6853238"/>
+          </a:xfrm>
+        </p:grpSpPr>
+        <p:sp>
+          <p:nvSpPr>
+            <p:cNvPr id="9" name="Freeform 5">
+              <a:extLst>
+                <a:ext uri="{FF2B5EF4-FFF2-40B4-BE49-F238E27FC236}">
+                  <a16:creationId xmlns:a16="http://schemas.microsoft.com/office/drawing/2014/main" id="{B8087084-CC7C-4D37-B821-F12CD3D29FD7}"/>
+                </a:ext>
+                <a:ext uri="{C183D7F6-B498-43B3-948B-1728B52AA6E4}">
+                  <adec:decorative xmlns:adec="http://schemas.microsoft.com/office/drawing/2017/decorative" val="1"/>
+                </a:ext>
+              </a:extLst>
+            </p:cNvPr>
+            <p:cNvSpPr/>
+            <p:nvPr>
+              <p:extLst>
+                <p:ext uri="{386F3935-93C4-4BCD-93E2-E3B085C9AB24}">
+                  <p16:designElem xmlns:p16="http://schemas.microsoft.com/office/powerpoint/2015/main" val="1"/>
+                </p:ext>
+              </p:extLst>
+            </p:nvPr>
+          </p:nvSpPr>
+          <p:spPr bwMode="auto">
+            <a:xfrm>
+              <a:off x="1306513" y="0"/>
+              <a:ext cx="3862388" cy="6843713"/>
+            </a:xfrm>
+            <a:custGeom>
+              <a:avLst/>
+              <a:gdLst/>
+              <a:ahLst/>
+              <a:cxnLst/>
+              <a:rect l="0" t="0" r="r" b="b"/>
+              <a:pathLst>
+                <a:path w="813" h="1440">
+                  <a:moveTo>
+                    <a:pt x="813" y="0"/>
+                  </a:moveTo>
+                  <a:cubicBezTo>
+                    <a:pt x="331" y="221"/>
+                    <a:pt x="0" y="1039"/>
+                    <a:pt x="435" y="1440"/>
+                  </a:cubicBezTo>
+                </a:path>
+              </a:pathLst>
+            </a:custGeom>
+            <a:noFill/>
+            <a:ln w="9525" cap="flat">
+              <a:solidFill>
+                <a:schemeClr val="tx1">
+                  <a:alpha val="20000"/>
+                </a:schemeClr>
+              </a:solidFill>
+              <a:prstDash val="solid"/>
+              <a:miter lim="800000"/>
+              <a:headEnd/>
+              <a:tailEnd/>
+            </a:ln>
+            <a:extLst>
+              <a:ext uri="{909E8E84-426E-40DD-AFC4-6F175D3DCCD1}">
+                <a14:hiddenFill xmlns:a14="http://schemas.microsoft.com/office/drawing/2010/main">
+                  <a:solidFill>
+                    <a:srgbClr val="FFFFFF"/>
+                  </a:solidFill>
+                </a14:hiddenFill>
+              </a:ext>
+            </a:extLst>
+          </p:spPr>
+          <p:txBody>
+            <a:bodyPr/>
+            <a:lstStyle/>
+            <a:p>
+              <a:endParaRPr lang="en-US"/>
+            </a:p>
+          </p:txBody>
+        </p:sp>
+        <p:sp>
+          <p:nvSpPr>
+            <p:cNvPr id="36" name="Freeform 6">
+              <a:extLst>
+                <a:ext uri="{FF2B5EF4-FFF2-40B4-BE49-F238E27FC236}">
+                  <a16:creationId xmlns:a16="http://schemas.microsoft.com/office/drawing/2014/main" id="{A27EF3C6-8AF8-41C0-B4DF-664F24087279}"/>
+                </a:ext>
+                <a:ext uri="{C183D7F6-B498-43B3-948B-1728B52AA6E4}">
+                  <adec:decorative xmlns:adec="http://schemas.microsoft.com/office/drawing/2017/decorative" val="1"/>
+                </a:ext>
+              </a:extLst>
+            </p:cNvPr>
+            <p:cNvSpPr/>
+            <p:nvPr>
+              <p:extLst>
+                <p:ext uri="{386F3935-93C4-4BCD-93E2-E3B085C9AB24}">
+                  <p16:designElem xmlns:p16="http://schemas.microsoft.com/office/powerpoint/2015/main" val="1"/>
+                </p:ext>
+              </p:extLst>
+            </p:nvPr>
+          </p:nvSpPr>
+          <p:spPr bwMode="auto">
+            <a:xfrm>
+              <a:off x="10626725" y="9525"/>
+              <a:ext cx="1539875" cy="555625"/>
+            </a:xfrm>
+            <a:custGeom>
+              <a:avLst/>
+              <a:gdLst/>
+              <a:ahLst/>
+              <a:cxnLst/>
+              <a:rect l="0" t="0" r="r" b="b"/>
+              <a:pathLst>
+                <a:path w="324" h="117">
+                  <a:moveTo>
+                    <a:pt x="324" y="117"/>
+                  </a:moveTo>
+                  <a:cubicBezTo>
+                    <a:pt x="223" y="64"/>
+                    <a:pt x="107" y="28"/>
+                    <a:pt x="0" y="0"/>
+                  </a:cubicBezTo>
+                </a:path>
+              </a:pathLst>
+            </a:custGeom>
+            <a:noFill/>
+            <a:ln w="9525" cap="flat">
+              <a:solidFill>
+                <a:schemeClr val="tx1">
+                  <a:alpha val="20000"/>
+                </a:schemeClr>
+              </a:solidFill>
+              <a:prstDash val="solid"/>
+              <a:miter lim="800000"/>
+              <a:headEnd/>
+              <a:tailEnd/>
+            </a:ln>
+            <a:extLst>
+              <a:ext uri="{909E8E84-426E-40DD-AFC4-6F175D3DCCD1}">
+                <a14:hiddenFill xmlns:a14="http://schemas.microsoft.com/office/drawing/2010/main">
+                  <a:solidFill>
+                    <a:srgbClr val="FFFFFF"/>
+                  </a:solidFill>
+                </a14:hiddenFill>
+              </a:ext>
+            </a:extLst>
+          </p:spPr>
+          <p:txBody>
+            <a:bodyPr/>
+            <a:lstStyle/>
+            <a:p>
+              <a:endParaRPr lang="en-US"/>
+            </a:p>
+          </p:txBody>
+        </p:sp>
+        <p:sp>
+          <p:nvSpPr>
+            <p:cNvPr id="37" name="Freeform 7">
+              <a:extLst>
+                <a:ext uri="{FF2B5EF4-FFF2-40B4-BE49-F238E27FC236}">
+                  <a16:creationId xmlns:a16="http://schemas.microsoft.com/office/drawing/2014/main" id="{46AD5CB4-13ED-4F2B-BA75-CA731F668A22}"/>
+                </a:ext>
+                <a:ext uri="{C183D7F6-B498-43B3-948B-1728B52AA6E4}">
+                  <adec:decorative xmlns:adec="http://schemas.microsoft.com/office/drawing/2017/decorative" val="1"/>
+                </a:ext>
+              </a:extLst>
+            </p:cNvPr>
+            <p:cNvSpPr/>
+            <p:nvPr>
+              <p:extLst>
+                <p:ext uri="{386F3935-93C4-4BCD-93E2-E3B085C9AB24}">
+                  <p16:designElem xmlns:p16="http://schemas.microsoft.com/office/powerpoint/2015/main" val="1"/>
+                </p:ext>
+              </p:extLst>
+            </p:nvPr>
+          </p:nvSpPr>
+          <p:spPr bwMode="auto">
+            <a:xfrm>
+              <a:off x="10247313" y="5013325"/>
+              <a:ext cx="1919288" cy="1830388"/>
+            </a:xfrm>
+            <a:custGeom>
+              <a:avLst/>
+              <a:gdLst/>
+              <a:ahLst/>
+              <a:cxnLst/>
+              <a:rect l="0" t="0" r="r" b="b"/>
+              <a:pathLst>
+                <a:path w="404" h="385">
+                  <a:moveTo>
+                    <a:pt x="0" y="385"/>
+                  </a:moveTo>
+                  <a:cubicBezTo>
+                    <a:pt x="146" y="272"/>
+                    <a:pt x="285" y="142"/>
+                    <a:pt x="404" y="0"/>
+                  </a:cubicBezTo>
+                </a:path>
+              </a:pathLst>
+            </a:custGeom>
+            <a:noFill/>
+            <a:ln w="9525" cap="flat">
+              <a:solidFill>
+                <a:schemeClr val="tx1">
+                  <a:alpha val="20000"/>
+                </a:schemeClr>
+              </a:solidFill>
+              <a:prstDash val="solid"/>
+              <a:miter lim="800000"/>
+              <a:headEnd/>
+              <a:tailEnd/>
+            </a:ln>
+            <a:extLst>
+              <a:ext uri="{909E8E84-426E-40DD-AFC4-6F175D3DCCD1}">
+                <a14:hiddenFill xmlns:a14="http://schemas.microsoft.com/office/drawing/2010/main">
+                  <a:solidFill>
+                    <a:srgbClr val="FFFFFF"/>
+                  </a:solidFill>
+                </a14:hiddenFill>
+              </a:ext>
+            </a:extLst>
+          </p:spPr>
+          <p:txBody>
+            <a:bodyPr/>
+            <a:lstStyle/>
+            <a:p>
+              <a:endParaRPr lang="en-US"/>
+            </a:p>
+          </p:txBody>
+        </p:sp>
+        <p:sp>
+          <p:nvSpPr>
+            <p:cNvPr id="38" name="Freeform 8">
+              <a:extLst>
+                <a:ext uri="{FF2B5EF4-FFF2-40B4-BE49-F238E27FC236}">
+                  <a16:creationId xmlns:a16="http://schemas.microsoft.com/office/drawing/2014/main" id="{6C2FD3B8-D702-4F83-BA99-D239212113F1}"/>
+                </a:ext>
+                <a:ext uri="{C183D7F6-B498-43B3-948B-1728B52AA6E4}">
+                  <adec:decorative xmlns:adec="http://schemas.microsoft.com/office/drawing/2017/decorative" val="1"/>
+                </a:ext>
+              </a:extLst>
+            </p:cNvPr>
+            <p:cNvSpPr/>
+            <p:nvPr>
+              <p:extLst>
+                <p:ext uri="{386F3935-93C4-4BCD-93E2-E3B085C9AB24}">
+                  <p16:designElem xmlns:p16="http://schemas.microsoft.com/office/powerpoint/2015/main" val="1"/>
+                </p:ext>
+              </p:extLst>
+            </p:nvPr>
+          </p:nvSpPr>
+          <p:spPr bwMode="auto">
+            <a:xfrm>
+              <a:off x="1120775" y="0"/>
+              <a:ext cx="3676650" cy="6843713"/>
+            </a:xfrm>
+            <a:custGeom>
+              <a:avLst/>
+              <a:gdLst/>
+              <a:ahLst/>
+              <a:cxnLst/>
+              <a:rect l="0" t="0" r="r" b="b"/>
+              <a:pathLst>
+                <a:path w="774" h="1440">
+                  <a:moveTo>
+                    <a:pt x="774" y="0"/>
+                  </a:moveTo>
+                  <a:cubicBezTo>
+                    <a:pt x="312" y="240"/>
+                    <a:pt x="0" y="1034"/>
+                    <a:pt x="411" y="1440"/>
+                  </a:cubicBezTo>
+                </a:path>
+              </a:pathLst>
+            </a:custGeom>
+            <a:noFill/>
+            <a:ln w="9525" cap="flat">
+              <a:solidFill>
+                <a:schemeClr val="tx1">
+                  <a:alpha val="20000"/>
+                </a:schemeClr>
+              </a:solidFill>
+              <a:prstDash val="dash"/>
+              <a:miter lim="800000"/>
+              <a:headEnd/>
+              <a:tailEnd/>
+            </a:ln>
+            <a:extLst>
+              <a:ext uri="{909E8E84-426E-40DD-AFC4-6F175D3DCCD1}">
+                <a14:hiddenFill xmlns:a14="http://schemas.microsoft.com/office/drawing/2010/main">
+                  <a:solidFill>
+                    <a:srgbClr val="FFFFFF"/>
+                  </a:solidFill>
+                </a14:hiddenFill>
+              </a:ext>
+            </a:extLst>
+          </p:spPr>
+          <p:txBody>
+            <a:bodyPr/>
+            <a:lstStyle/>
+            <a:p>
+              <a:endParaRPr lang="en-US"/>
+            </a:p>
+          </p:txBody>
+        </p:sp>
+        <p:sp>
+          <p:nvSpPr>
+            <p:cNvPr id="39" name="Freeform 9">
+              <a:extLst>
+                <a:ext uri="{FF2B5EF4-FFF2-40B4-BE49-F238E27FC236}">
+                  <a16:creationId xmlns:a16="http://schemas.microsoft.com/office/drawing/2014/main" id="{1AF0D977-DBC6-44B7-93FB-3F76406CF0A4}"/>
+                </a:ext>
+                <a:ext uri="{C183D7F6-B498-43B3-948B-1728B52AA6E4}">
+                  <adec:decorative xmlns:adec="http://schemas.microsoft.com/office/drawing/2017/decorative" val="1"/>
+                </a:ext>
+              </a:extLst>
+            </p:cNvPr>
+            <p:cNvSpPr/>
+            <p:nvPr>
+              <p:extLst>
+                <p:ext uri="{386F3935-93C4-4BCD-93E2-E3B085C9AB24}">
+                  <p16:designElem xmlns:p16="http://schemas.microsoft.com/office/powerpoint/2015/main" val="1"/>
+                </p:ext>
+              </p:extLst>
+            </p:nvPr>
+          </p:nvSpPr>
+          <p:spPr bwMode="auto">
+            <a:xfrm>
+              <a:off x="11202988" y="9525"/>
+              <a:ext cx="963613" cy="366713"/>
+            </a:xfrm>
+            <a:custGeom>
+              <a:avLst/>
+              <a:gdLst/>
+              <a:ahLst/>
+              <a:cxnLst/>
+              <a:rect l="0" t="0" r="r" b="b"/>
+              <a:pathLst>
+                <a:path w="203" h="77">
+                  <a:moveTo>
+                    <a:pt x="203" y="77"/>
+                  </a:moveTo>
+                  <a:cubicBezTo>
+                    <a:pt x="138" y="46"/>
+                    <a:pt x="68" y="21"/>
+                    <a:pt x="0" y="0"/>
+                  </a:cubicBezTo>
+                </a:path>
+              </a:pathLst>
+            </a:custGeom>
+            <a:noFill/>
+            <a:ln w="9525" cap="flat">
+              <a:solidFill>
+                <a:schemeClr val="tx1">
+                  <a:alpha val="20000"/>
+                </a:schemeClr>
+              </a:solidFill>
+              <a:prstDash val="dash"/>
+              <a:miter lim="800000"/>
+              <a:headEnd/>
+              <a:tailEnd/>
+            </a:ln>
+            <a:extLst>
+              <a:ext uri="{909E8E84-426E-40DD-AFC4-6F175D3DCCD1}">
+                <a14:hiddenFill xmlns:a14="http://schemas.microsoft.com/office/drawing/2010/main">
+                  <a:solidFill>
+                    <a:srgbClr val="FFFFFF"/>
+                  </a:solidFill>
+                </a14:hiddenFill>
+              </a:ext>
+            </a:extLst>
+          </p:spPr>
+          <p:txBody>
+            <a:bodyPr/>
+            <a:lstStyle/>
+            <a:p>
+              <a:endParaRPr lang="en-US"/>
+            </a:p>
+          </p:txBody>
+        </p:sp>
+        <p:sp>
+          <p:nvSpPr>
+            <p:cNvPr id="40" name="Freeform 10">
+              <a:extLst>
+                <a:ext uri="{FF2B5EF4-FFF2-40B4-BE49-F238E27FC236}">
+                  <a16:creationId xmlns:a16="http://schemas.microsoft.com/office/drawing/2014/main" id="{B3ED27DF-D17E-4922-8394-821ED92539FE}"/>
+                </a:ext>
+                <a:ext uri="{C183D7F6-B498-43B3-948B-1728B52AA6E4}">
+                  <adec:decorative xmlns:adec="http://schemas.microsoft.com/office/drawing/2017/decorative" val="1"/>
+                </a:ext>
+              </a:extLst>
+            </p:cNvPr>
+            <p:cNvSpPr/>
+            <p:nvPr>
+              <p:extLst>
+                <p:ext uri="{386F3935-93C4-4BCD-93E2-E3B085C9AB24}">
+                  <p16:designElem xmlns:p16="http://schemas.microsoft.com/office/powerpoint/2015/main" val="1"/>
+                </p:ext>
+              </p:extLst>
+            </p:nvPr>
+          </p:nvSpPr>
+          <p:spPr bwMode="auto">
+            <a:xfrm>
+              <a:off x="10494963" y="5275263"/>
+              <a:ext cx="1666875" cy="1577975"/>
+            </a:xfrm>
+            <a:custGeom>
+              <a:avLst/>
+              <a:gdLst/>
+              <a:ahLst/>
+              <a:cxnLst/>
+              <a:rect l="0" t="0" r="r" b="b"/>
+              <a:pathLst>
+                <a:path w="351" h="332">
+                  <a:moveTo>
+                    <a:pt x="0" y="332"/>
+                  </a:moveTo>
+                  <a:cubicBezTo>
+                    <a:pt x="125" y="232"/>
+                    <a:pt x="245" y="121"/>
+                    <a:pt x="351" y="0"/>
+                  </a:cubicBezTo>
+                </a:path>
+              </a:pathLst>
+            </a:custGeom>
+            <a:noFill/>
+            <a:ln w="9525" cap="flat">
+              <a:solidFill>
+                <a:schemeClr val="tx1">
+                  <a:alpha val="20000"/>
+                </a:schemeClr>
+              </a:solidFill>
+              <a:prstDash val="dash"/>
+              <a:miter lim="800000"/>
+              <a:headEnd/>
+              <a:tailEnd/>
+            </a:ln>
+            <a:extLst>
+              <a:ext uri="{909E8E84-426E-40DD-AFC4-6F175D3DCCD1}">
+                <a14:hiddenFill xmlns:a14="http://schemas.microsoft.com/office/drawing/2010/main">
+                  <a:solidFill>
+                    <a:srgbClr val="FFFFFF"/>
+                  </a:solidFill>
+                </a14:hiddenFill>
+              </a:ext>
+            </a:extLst>
+          </p:spPr>
+          <p:txBody>
+            <a:bodyPr/>
+            <a:lstStyle/>
+            <a:p>
+              <a:endParaRPr lang="en-US"/>
+            </a:p>
+          </p:txBody>
+        </p:sp>
+        <p:sp>
+          <p:nvSpPr>
+            <p:cNvPr id="41" name="Freeform 11">
+              <a:extLst>
+                <a:ext uri="{FF2B5EF4-FFF2-40B4-BE49-F238E27FC236}">
+                  <a16:creationId xmlns:a16="http://schemas.microsoft.com/office/drawing/2014/main" id="{800084EB-3C31-445C-8B2E-F43BA7ED36FE}"/>
+                </a:ext>
+                <a:ext uri="{C183D7F6-B498-43B3-948B-1728B52AA6E4}">
+                  <adec:decorative xmlns:adec="http://schemas.microsoft.com/office/drawing/2017/decorative" val="1"/>
+                </a:ext>
+              </a:extLst>
+            </p:cNvPr>
+            <p:cNvSpPr/>
+            <p:nvPr>
+              <p:extLst>
+                <p:ext uri="{386F3935-93C4-4BCD-93E2-E3B085C9AB24}">
+                  <p16:designElem xmlns:p16="http://schemas.microsoft.com/office/powerpoint/2015/main" val="1"/>
+                </p:ext>
+              </p:extLst>
+            </p:nvPr>
+          </p:nvSpPr>
+          <p:spPr bwMode="auto">
+            <a:xfrm>
+              <a:off x="1001713" y="0"/>
+              <a:ext cx="3621088" cy="6843713"/>
+            </a:xfrm>
+            <a:custGeom>
+              <a:avLst/>
+              <a:gdLst/>
+              <a:ahLst/>
+              <a:cxnLst/>
+              <a:rect l="0" t="0" r="r" b="b"/>
+              <a:pathLst>
+                <a:path w="762" h="1440">
+                  <a:moveTo>
+                    <a:pt x="762" y="0"/>
+                  </a:moveTo>
+                  <a:cubicBezTo>
+                    <a:pt x="308" y="245"/>
+                    <a:pt x="0" y="1033"/>
+                    <a:pt x="403" y="1440"/>
+                  </a:cubicBezTo>
+                </a:path>
+              </a:pathLst>
+            </a:custGeom>
+            <a:noFill/>
+            <a:ln w="9525" cap="flat">
+              <a:solidFill>
+                <a:schemeClr val="tx1">
+                  <a:alpha val="20000"/>
+                </a:schemeClr>
+              </a:solidFill>
+              <a:prstDash val="solid"/>
+              <a:miter lim="800000"/>
+              <a:headEnd/>
+              <a:tailEnd/>
+            </a:ln>
+            <a:extLst>
+              <a:ext uri="{909E8E84-426E-40DD-AFC4-6F175D3DCCD1}">
+                <a14:hiddenFill xmlns:a14="http://schemas.microsoft.com/office/drawing/2010/main">
+                  <a:solidFill>
+                    <a:srgbClr val="FFFFFF"/>
+                  </a:solidFill>
+                </a14:hiddenFill>
+              </a:ext>
+            </a:extLst>
+          </p:spPr>
+          <p:txBody>
+            <a:bodyPr/>
+            <a:lstStyle/>
+            <a:p>
+              <a:endParaRPr lang="en-US"/>
+            </a:p>
+          </p:txBody>
+        </p:sp>
+        <p:sp>
+          <p:nvSpPr>
+            <p:cNvPr id="42" name="Freeform 12">
+              <a:extLst>
+                <a:ext uri="{FF2B5EF4-FFF2-40B4-BE49-F238E27FC236}">
+                  <a16:creationId xmlns:a16="http://schemas.microsoft.com/office/drawing/2014/main" id="{5EE7F4D6-BE2E-41A9-A417-BA1AE4583DBC}"/>
+                </a:ext>
+                <a:ext uri="{C183D7F6-B498-43B3-948B-1728B52AA6E4}">
+                  <adec:decorative xmlns:adec="http://schemas.microsoft.com/office/drawing/2017/decorative" val="1"/>
+                </a:ext>
+              </a:extLst>
+            </p:cNvPr>
+            <p:cNvSpPr/>
+            <p:nvPr>
+              <p:extLst>
+                <p:ext uri="{386F3935-93C4-4BCD-93E2-E3B085C9AB24}">
+                  <p16:designElem xmlns:p16="http://schemas.microsoft.com/office/powerpoint/2015/main" val="1"/>
+                </p:ext>
+              </p:extLst>
+            </p:nvPr>
+          </p:nvSpPr>
+          <p:spPr bwMode="auto">
+            <a:xfrm>
+              <a:off x="11501438" y="9525"/>
+              <a:ext cx="665163" cy="257175"/>
+            </a:xfrm>
+            <a:custGeom>
+              <a:avLst/>
+              <a:gdLst/>
+              <a:ahLst/>
+              <a:cxnLst/>
+              <a:rect l="0" t="0" r="r" b="b"/>
+              <a:pathLst>
+                <a:path w="140" h="54">
+                  <a:moveTo>
+                    <a:pt x="140" y="54"/>
+                  </a:moveTo>
+                  <a:cubicBezTo>
+                    <a:pt x="95" y="34"/>
+                    <a:pt x="48" y="16"/>
+                    <a:pt x="0" y="0"/>
+                  </a:cubicBezTo>
+                </a:path>
+              </a:pathLst>
+            </a:custGeom>
+            <a:noFill/>
+            <a:ln w="9525" cap="flat">
+              <a:solidFill>
+                <a:schemeClr val="tx1">
+                  <a:alpha val="20000"/>
+                </a:schemeClr>
+              </a:solidFill>
+              <a:prstDash val="solid"/>
+              <a:miter lim="800000"/>
+              <a:headEnd/>
+              <a:tailEnd/>
+            </a:ln>
+            <a:extLst>
+              <a:ext uri="{909E8E84-426E-40DD-AFC4-6F175D3DCCD1}">
+                <a14:hiddenFill xmlns:a14="http://schemas.microsoft.com/office/drawing/2010/main">
+                  <a:solidFill>
+                    <a:srgbClr val="FFFFFF"/>
+                  </a:solidFill>
+                </a14:hiddenFill>
+              </a:ext>
+            </a:extLst>
+          </p:spPr>
+          <p:txBody>
+            <a:bodyPr/>
+            <a:lstStyle/>
+            <a:p>
+              <a:endParaRPr lang="en-US"/>
+            </a:p>
+          </p:txBody>
+        </p:sp>
+        <p:sp>
+          <p:nvSpPr>
+            <p:cNvPr id="43" name="Freeform 13">
+              <a:extLst>
+                <a:ext uri="{FF2B5EF4-FFF2-40B4-BE49-F238E27FC236}">
+                  <a16:creationId xmlns:a16="http://schemas.microsoft.com/office/drawing/2014/main" id="{8805A789-4E10-46CF-A22B-8841C1CDFA3A}"/>
+                </a:ext>
+                <a:ext uri="{C183D7F6-B498-43B3-948B-1728B52AA6E4}">
+                  <adec:decorative xmlns:adec="http://schemas.microsoft.com/office/drawing/2017/decorative" val="1"/>
+                </a:ext>
+              </a:extLst>
+            </p:cNvPr>
+            <p:cNvSpPr/>
+            <p:nvPr>
+              <p:extLst>
+                <p:ext uri="{386F3935-93C4-4BCD-93E2-E3B085C9AB24}">
+                  <p16:designElem xmlns:p16="http://schemas.microsoft.com/office/powerpoint/2015/main" val="1"/>
+                </p:ext>
+              </p:extLst>
+            </p:nvPr>
+          </p:nvSpPr>
+          <p:spPr bwMode="auto">
+            <a:xfrm>
+              <a:off x="10641013" y="5408613"/>
+              <a:ext cx="1525588" cy="1435100"/>
+            </a:xfrm>
+            <a:custGeom>
+              <a:avLst/>
+              <a:gdLst/>
+              <a:ahLst/>
+              <a:cxnLst/>
+              <a:rect l="0" t="0" r="r" b="b"/>
+              <a:pathLst>
+                <a:path w="321" h="302">
+                  <a:moveTo>
+                    <a:pt x="0" y="302"/>
+                  </a:moveTo>
+                  <a:cubicBezTo>
+                    <a:pt x="114" y="210"/>
+                    <a:pt x="223" y="109"/>
+                    <a:pt x="321" y="0"/>
+                  </a:cubicBezTo>
+                </a:path>
+              </a:pathLst>
+            </a:custGeom>
+            <a:noFill/>
+            <a:ln w="9525" cap="flat">
+              <a:solidFill>
+                <a:schemeClr val="tx1">
+                  <a:alpha val="20000"/>
+                </a:schemeClr>
+              </a:solidFill>
+              <a:prstDash val="solid"/>
+              <a:miter lim="800000"/>
+              <a:headEnd/>
+              <a:tailEnd/>
+            </a:ln>
+            <a:extLst>
+              <a:ext uri="{909E8E84-426E-40DD-AFC4-6F175D3DCCD1}">
+                <a14:hiddenFill xmlns:a14="http://schemas.microsoft.com/office/drawing/2010/main">
+                  <a:solidFill>
+                    <a:srgbClr val="FFFFFF"/>
+                  </a:solidFill>
+                </a14:hiddenFill>
+              </a:ext>
+            </a:extLst>
+          </p:spPr>
+          <p:txBody>
+            <a:bodyPr/>
+            <a:lstStyle/>
+            <a:p>
+              <a:endParaRPr lang="en-US"/>
+            </a:p>
+          </p:txBody>
+        </p:sp>
+        <p:sp>
+          <p:nvSpPr>
+            <p:cNvPr id="44" name="Freeform 14">
+              <a:extLst>
+                <a:ext uri="{FF2B5EF4-FFF2-40B4-BE49-F238E27FC236}">
+                  <a16:creationId xmlns:a16="http://schemas.microsoft.com/office/drawing/2014/main" id="{9BD0D630-7987-48B7-A636-0ED234E22ECE}"/>
+                </a:ext>
+                <a:ext uri="{C183D7F6-B498-43B3-948B-1728B52AA6E4}">
+                  <adec:decorative xmlns:adec="http://schemas.microsoft.com/office/drawing/2017/decorative" val="1"/>
+                </a:ext>
+              </a:extLst>
+            </p:cNvPr>
+            <p:cNvSpPr/>
+            <p:nvPr>
+              <p:extLst>
+                <p:ext uri="{386F3935-93C4-4BCD-93E2-E3B085C9AB24}">
+                  <p16:designElem xmlns:p16="http://schemas.microsoft.com/office/powerpoint/2015/main" val="1"/>
+                </p:ext>
+              </p:extLst>
+            </p:nvPr>
+          </p:nvSpPr>
+          <p:spPr bwMode="auto">
+            <a:xfrm>
+              <a:off x="1001713" y="0"/>
+              <a:ext cx="3244850" cy="6843713"/>
+            </a:xfrm>
+            <a:custGeom>
+              <a:avLst/>
+              <a:gdLst/>
+              <a:ahLst/>
+              <a:cxnLst/>
+              <a:rect l="0" t="0" r="r" b="b"/>
+              <a:pathLst>
+                <a:path w="683" h="1440">
+                  <a:moveTo>
+                    <a:pt x="683" y="0"/>
+                  </a:moveTo>
+                  <a:cubicBezTo>
+                    <a:pt x="258" y="256"/>
+                    <a:pt x="0" y="1041"/>
+                    <a:pt x="355" y="1440"/>
+                  </a:cubicBezTo>
+                </a:path>
+              </a:pathLst>
+            </a:custGeom>
+            <a:noFill/>
+            <a:ln w="9525" cap="flat">
+              <a:solidFill>
+                <a:schemeClr val="tx1">
+                  <a:alpha val="20000"/>
+                </a:schemeClr>
+              </a:solidFill>
+              <a:prstDash val="solid"/>
+              <a:miter lim="800000"/>
+              <a:headEnd/>
+              <a:tailEnd/>
+            </a:ln>
+            <a:extLst>
+              <a:ext uri="{909E8E84-426E-40DD-AFC4-6F175D3DCCD1}">
+                <a14:hiddenFill xmlns:a14="http://schemas.microsoft.com/office/drawing/2010/main">
+                  <a:solidFill>
+                    <a:srgbClr val="FFFFFF"/>
+                  </a:solidFill>
+                </a14:hiddenFill>
+              </a:ext>
+            </a:extLst>
+          </p:spPr>
+          <p:txBody>
+            <a:bodyPr/>
+            <a:lstStyle/>
+            <a:p>
+              <a:endParaRPr lang="en-US"/>
+            </a:p>
+          </p:txBody>
+        </p:sp>
+        <p:sp>
+          <p:nvSpPr>
+            <p:cNvPr id="45" name="Freeform 15">
+              <a:extLst>
+                <a:ext uri="{FF2B5EF4-FFF2-40B4-BE49-F238E27FC236}">
+                  <a16:creationId xmlns:a16="http://schemas.microsoft.com/office/drawing/2014/main" id="{F4E7D46D-851A-4DA9-B24D-19DAE1FCF2C1}"/>
+                </a:ext>
+                <a:ext uri="{C183D7F6-B498-43B3-948B-1728B52AA6E4}">
+                  <adec:decorative xmlns:adec="http://schemas.microsoft.com/office/drawing/2017/decorative" val="1"/>
+                </a:ext>
+              </a:extLst>
+            </p:cNvPr>
+            <p:cNvSpPr/>
+            <p:nvPr>
+              <p:extLst>
+                <p:ext uri="{386F3935-93C4-4BCD-93E2-E3B085C9AB24}">
+                  <p16:designElem xmlns:p16="http://schemas.microsoft.com/office/powerpoint/2015/main" val="1"/>
+                </p:ext>
+              </p:extLst>
+            </p:nvPr>
+          </p:nvSpPr>
+          <p:spPr bwMode="auto">
+            <a:xfrm>
+              <a:off x="10802938" y="5518150"/>
+              <a:ext cx="1363663" cy="1325563"/>
+            </a:xfrm>
+            <a:custGeom>
+              <a:avLst/>
+              <a:gdLst/>
+              <a:ahLst/>
+              <a:cxnLst/>
+              <a:rect l="0" t="0" r="r" b="b"/>
+              <a:pathLst>
+                <a:path w="287" h="279">
+                  <a:moveTo>
+                    <a:pt x="0" y="279"/>
+                  </a:moveTo>
+                  <a:cubicBezTo>
+                    <a:pt x="101" y="193"/>
+                    <a:pt x="198" y="100"/>
+                    <a:pt x="287" y="0"/>
+                  </a:cubicBezTo>
+                </a:path>
+              </a:pathLst>
+            </a:custGeom>
+            <a:noFill/>
+            <a:ln w="9525" cap="flat">
+              <a:solidFill>
+                <a:schemeClr val="tx1">
+                  <a:alpha val="20000"/>
+                </a:schemeClr>
+              </a:solidFill>
+              <a:prstDash val="solid"/>
+              <a:miter lim="800000"/>
+              <a:headEnd/>
+              <a:tailEnd/>
+            </a:ln>
+            <a:extLst>
+              <a:ext uri="{909E8E84-426E-40DD-AFC4-6F175D3DCCD1}">
+                <a14:hiddenFill xmlns:a14="http://schemas.microsoft.com/office/drawing/2010/main">
+                  <a:solidFill>
+                    <a:srgbClr val="FFFFFF"/>
+                  </a:solidFill>
+                </a14:hiddenFill>
+              </a:ext>
+            </a:extLst>
+          </p:spPr>
+          <p:txBody>
+            <a:bodyPr/>
+            <a:lstStyle/>
+            <a:p>
+              <a:endParaRPr lang="en-US"/>
+            </a:p>
+          </p:txBody>
+        </p:sp>
+        <p:sp>
+          <p:nvSpPr>
+            <p:cNvPr id="46" name="Freeform 16">
+              <a:extLst>
+                <a:ext uri="{FF2B5EF4-FFF2-40B4-BE49-F238E27FC236}">
+                  <a16:creationId xmlns:a16="http://schemas.microsoft.com/office/drawing/2014/main" id="{BA38A754-A53E-469C-B89B-6C7FF9607985}"/>
+                </a:ext>
+                <a:ext uri="{C183D7F6-B498-43B3-948B-1728B52AA6E4}">
+                  <adec:decorative xmlns:adec="http://schemas.microsoft.com/office/drawing/2017/decorative" val="1"/>
+                </a:ext>
+              </a:extLst>
+            </p:cNvPr>
+            <p:cNvSpPr/>
+            <p:nvPr>
+              <p:extLst>
+                <p:ext uri="{386F3935-93C4-4BCD-93E2-E3B085C9AB24}">
+                  <p16:designElem xmlns:p16="http://schemas.microsoft.com/office/powerpoint/2015/main" val="1"/>
+                </p:ext>
+              </p:extLst>
+            </p:nvPr>
+          </p:nvSpPr>
+          <p:spPr bwMode="auto">
+            <a:xfrm>
+              <a:off x="889000" y="0"/>
+              <a:ext cx="3230563" cy="6843713"/>
+            </a:xfrm>
+            <a:custGeom>
+              <a:avLst/>
+              <a:gdLst/>
+              <a:ahLst/>
+              <a:cxnLst/>
+              <a:rect l="0" t="0" r="r" b="b"/>
+              <a:pathLst>
+                <a:path w="680" h="1440">
+                  <a:moveTo>
+                    <a:pt x="680" y="0"/>
+                  </a:moveTo>
+                  <a:cubicBezTo>
+                    <a:pt x="257" y="265"/>
+                    <a:pt x="0" y="1026"/>
+                    <a:pt x="337" y="1440"/>
+                  </a:cubicBezTo>
+                </a:path>
+              </a:pathLst>
+            </a:custGeom>
+            <a:noFill/>
+            <a:ln w="9525" cap="flat">
+              <a:solidFill>
+                <a:schemeClr val="tx1">
+                  <a:alpha val="20000"/>
+                </a:schemeClr>
+              </a:solidFill>
+              <a:prstDash val="solid"/>
+              <a:miter lim="800000"/>
+              <a:headEnd/>
+              <a:tailEnd/>
+            </a:ln>
+            <a:extLst>
+              <a:ext uri="{909E8E84-426E-40DD-AFC4-6F175D3DCCD1}">
+                <a14:hiddenFill xmlns:a14="http://schemas.microsoft.com/office/drawing/2010/main">
+                  <a:solidFill>
+                    <a:srgbClr val="FFFFFF"/>
+                  </a:solidFill>
+                </a14:hiddenFill>
+              </a:ext>
+            </a:extLst>
+          </p:spPr>
+          <p:txBody>
+            <a:bodyPr/>
+            <a:lstStyle/>
+            <a:p>
+              <a:endParaRPr lang="en-US"/>
+            </a:p>
+          </p:txBody>
+        </p:sp>
+        <p:sp>
+          <p:nvSpPr>
+            <p:cNvPr id="47" name="Freeform 17">
+              <a:extLst>
+                <a:ext uri="{FF2B5EF4-FFF2-40B4-BE49-F238E27FC236}">
+                  <a16:creationId xmlns:a16="http://schemas.microsoft.com/office/drawing/2014/main" id="{CAC17457-E557-440A-B5E0-40DFEEC89923}"/>
+                </a:ext>
+                <a:ext uri="{C183D7F6-B498-43B3-948B-1728B52AA6E4}">
+                  <adec:decorative xmlns:adec="http://schemas.microsoft.com/office/drawing/2017/decorative" val="1"/>
+                </a:ext>
+              </a:extLst>
+            </p:cNvPr>
+            <p:cNvSpPr/>
+            <p:nvPr>
+              <p:extLst>
+                <p:ext uri="{386F3935-93C4-4BCD-93E2-E3B085C9AB24}">
+                  <p16:designElem xmlns:p16="http://schemas.microsoft.com/office/powerpoint/2015/main" val="1"/>
+                </p:ext>
+              </p:extLst>
+            </p:nvPr>
+          </p:nvSpPr>
+          <p:spPr bwMode="auto">
+            <a:xfrm>
+              <a:off x="10979150" y="5694363"/>
+              <a:ext cx="1187450" cy="1149350"/>
+            </a:xfrm>
+            <a:custGeom>
+              <a:avLst/>
+              <a:gdLst/>
+              <a:ahLst/>
+              <a:cxnLst/>
+              <a:rect l="0" t="0" r="r" b="b"/>
+              <a:pathLst>
+                <a:path w="250" h="242">
+                  <a:moveTo>
+                    <a:pt x="0" y="242"/>
+                  </a:moveTo>
+                  <a:cubicBezTo>
+                    <a:pt x="88" y="166"/>
+                    <a:pt x="172" y="85"/>
+                    <a:pt x="250" y="0"/>
+                  </a:cubicBezTo>
+                </a:path>
+              </a:pathLst>
+            </a:custGeom>
+            <a:noFill/>
+            <a:ln w="9525" cap="flat">
+              <a:solidFill>
+                <a:schemeClr val="tx1">
+                  <a:alpha val="20000"/>
+                </a:schemeClr>
+              </a:solidFill>
+              <a:prstDash val="solid"/>
+              <a:miter lim="800000"/>
+              <a:headEnd/>
+              <a:tailEnd/>
+            </a:ln>
+            <a:extLst>
+              <a:ext uri="{909E8E84-426E-40DD-AFC4-6F175D3DCCD1}">
+                <a14:hiddenFill xmlns:a14="http://schemas.microsoft.com/office/drawing/2010/main">
+                  <a:solidFill>
+                    <a:srgbClr val="FFFFFF"/>
+                  </a:solidFill>
+                </a14:hiddenFill>
+              </a:ext>
+            </a:extLst>
+          </p:spPr>
+          <p:txBody>
+            <a:bodyPr/>
+            <a:lstStyle/>
+            <a:p>
+              <a:endParaRPr lang="en-US"/>
+            </a:p>
+          </p:txBody>
+        </p:sp>
+        <p:sp>
+          <p:nvSpPr>
+            <p:cNvPr id="48" name="Freeform 18">
+              <a:extLst>
+                <a:ext uri="{FF2B5EF4-FFF2-40B4-BE49-F238E27FC236}">
+                  <a16:creationId xmlns:a16="http://schemas.microsoft.com/office/drawing/2014/main" id="{4D697814-F310-40D2-8E79-93C1881074D3}"/>
+                </a:ext>
+                <a:ext uri="{C183D7F6-B498-43B3-948B-1728B52AA6E4}">
+                  <adec:decorative xmlns:adec="http://schemas.microsoft.com/office/drawing/2017/decorative" val="1"/>
+                </a:ext>
+              </a:extLst>
+            </p:cNvPr>
+            <p:cNvSpPr/>
+            <p:nvPr>
+              <p:extLst>
+                <p:ext uri="{386F3935-93C4-4BCD-93E2-E3B085C9AB24}">
+                  <p16:designElem xmlns:p16="http://schemas.microsoft.com/office/powerpoint/2015/main" val="1"/>
+                </p:ext>
+              </p:extLst>
+            </p:nvPr>
+          </p:nvSpPr>
+          <p:spPr bwMode="auto">
+            <a:xfrm>
+              <a:off x="484188" y="0"/>
+              <a:ext cx="3421063" cy="6843713"/>
+            </a:xfrm>
+            <a:custGeom>
+              <a:avLst/>
+              <a:gdLst/>
+              <a:ahLst/>
+              <a:cxnLst/>
+              <a:rect l="0" t="0" r="r" b="b"/>
+              <a:pathLst>
+                <a:path w="720" h="1440">
+                  <a:moveTo>
+                    <a:pt x="720" y="0"/>
+                  </a:moveTo>
+                  <a:cubicBezTo>
+                    <a:pt x="316" y="282"/>
+                    <a:pt x="0" y="1018"/>
+                    <a:pt x="362" y="1440"/>
+                  </a:cubicBezTo>
+                </a:path>
+              </a:pathLst>
+            </a:custGeom>
+            <a:noFill/>
+            <a:ln w="9525" cap="flat">
+              <a:solidFill>
+                <a:schemeClr val="tx1">
+                  <a:alpha val="20000"/>
+                </a:schemeClr>
+              </a:solidFill>
+              <a:prstDash val="solid"/>
+              <a:miter lim="800000"/>
+              <a:headEnd/>
+              <a:tailEnd/>
+            </a:ln>
+            <a:extLst>
+              <a:ext uri="{909E8E84-426E-40DD-AFC4-6F175D3DCCD1}">
+                <a14:hiddenFill xmlns:a14="http://schemas.microsoft.com/office/drawing/2010/main">
+                  <a:solidFill>
+                    <a:srgbClr val="FFFFFF"/>
+                  </a:solidFill>
+                </a14:hiddenFill>
+              </a:ext>
+            </a:extLst>
+          </p:spPr>
+          <p:txBody>
+            <a:bodyPr/>
+            <a:lstStyle/>
+            <a:p>
+              <a:endParaRPr lang="en-US"/>
+            </a:p>
+          </p:txBody>
+        </p:sp>
+        <p:sp>
+          <p:nvSpPr>
+            <p:cNvPr id="49" name="Freeform 19">
+              <a:extLst>
+                <a:ext uri="{FF2B5EF4-FFF2-40B4-BE49-F238E27FC236}">
+                  <a16:creationId xmlns:a16="http://schemas.microsoft.com/office/drawing/2014/main" id="{0CA691A3-EEBB-46A7-A973-B1E2DD112C84}"/>
+                </a:ext>
+                <a:ext uri="{C183D7F6-B498-43B3-948B-1728B52AA6E4}">
+                  <adec:decorative xmlns:adec="http://schemas.microsoft.com/office/drawing/2017/decorative" val="1"/>
+                </a:ext>
+              </a:extLst>
+            </p:cNvPr>
+            <p:cNvSpPr/>
+            <p:nvPr>
+              <p:extLst>
+                <p:ext uri="{386F3935-93C4-4BCD-93E2-E3B085C9AB24}">
+                  <p16:designElem xmlns:p16="http://schemas.microsoft.com/office/powerpoint/2015/main" val="1"/>
+                </p:ext>
+              </p:extLst>
+            </p:nvPr>
+          </p:nvSpPr>
+          <p:spPr bwMode="auto">
+            <a:xfrm>
+              <a:off x="11287125" y="6049963"/>
+              <a:ext cx="879475" cy="793750"/>
+            </a:xfrm>
+            <a:custGeom>
+              <a:avLst/>
+              <a:gdLst/>
+              <a:ahLst/>
+              <a:cxnLst/>
+              <a:rect l="0" t="0" r="r" b="b"/>
+              <a:pathLst>
+                <a:path w="185" h="167">
+                  <a:moveTo>
+                    <a:pt x="0" y="167"/>
+                  </a:moveTo>
+                  <a:cubicBezTo>
+                    <a:pt x="63" y="114"/>
+                    <a:pt x="125" y="58"/>
+                    <a:pt x="185" y="0"/>
+                  </a:cubicBezTo>
+                </a:path>
+              </a:pathLst>
+            </a:custGeom>
+            <a:noFill/>
+            <a:ln w="9525" cap="flat">
+              <a:solidFill>
+                <a:schemeClr val="tx1">
+                  <a:alpha val="20000"/>
+                </a:schemeClr>
+              </a:solidFill>
+              <a:prstDash val="solid"/>
+              <a:miter lim="800000"/>
+              <a:headEnd/>
+              <a:tailEnd/>
+            </a:ln>
+            <a:extLst>
+              <a:ext uri="{909E8E84-426E-40DD-AFC4-6F175D3DCCD1}">
+                <a14:hiddenFill xmlns:a14="http://schemas.microsoft.com/office/drawing/2010/main">
+                  <a:solidFill>
+                    <a:srgbClr val="FFFFFF"/>
+                  </a:solidFill>
+                </a14:hiddenFill>
+              </a:ext>
+            </a:extLst>
+          </p:spPr>
+          <p:txBody>
+            <a:bodyPr/>
+            <a:lstStyle/>
+            <a:p>
+              <a:endParaRPr lang="en-US"/>
+            </a:p>
+          </p:txBody>
+        </p:sp>
+        <p:sp>
+          <p:nvSpPr>
+            <p:cNvPr id="50" name="Freeform 20">
+              <a:extLst>
+                <a:ext uri="{FF2B5EF4-FFF2-40B4-BE49-F238E27FC236}">
+                  <a16:creationId xmlns:a16="http://schemas.microsoft.com/office/drawing/2014/main" id="{B7361B78-110B-4437-8058-4E05A423434F}"/>
+                </a:ext>
+                <a:ext uri="{C183D7F6-B498-43B3-948B-1728B52AA6E4}">
+                  <adec:decorative xmlns:adec="http://schemas.microsoft.com/office/drawing/2017/decorative" val="1"/>
+                </a:ext>
+              </a:extLst>
+            </p:cNvPr>
+            <p:cNvSpPr/>
+            <p:nvPr>
+              <p:extLst>
+                <p:ext uri="{386F3935-93C4-4BCD-93E2-E3B085C9AB24}">
+                  <p16:designElem xmlns:p16="http://schemas.microsoft.com/office/powerpoint/2015/main" val="1"/>
+                </p:ext>
+              </p:extLst>
+            </p:nvPr>
+          </p:nvSpPr>
+          <p:spPr bwMode="auto">
+            <a:xfrm>
+              <a:off x="598488" y="0"/>
+              <a:ext cx="2717800" cy="6843713"/>
+            </a:xfrm>
+            <a:custGeom>
+              <a:avLst/>
+              <a:gdLst/>
+              <a:ahLst/>
+              <a:cxnLst/>
+              <a:rect l="0" t="0" r="r" b="b"/>
+              <a:pathLst>
+                <a:path w="572" h="1440">
+                  <a:moveTo>
+                    <a:pt x="572" y="0"/>
+                  </a:moveTo>
+                  <a:cubicBezTo>
+                    <a:pt x="213" y="320"/>
+                    <a:pt x="0" y="979"/>
+                    <a:pt x="164" y="1440"/>
+                  </a:cubicBezTo>
+                </a:path>
+              </a:pathLst>
+            </a:custGeom>
+            <a:noFill/>
+            <a:ln w="12700" cap="flat">
+              <a:solidFill>
+                <a:schemeClr val="tx1">
+                  <a:alpha val="20000"/>
+                </a:schemeClr>
+              </a:solidFill>
+              <a:prstDash val="dashDot"/>
+              <a:miter lim="800000"/>
+              <a:headEnd/>
+              <a:tailEnd/>
+            </a:ln>
+            <a:extLst>
+              <a:ext uri="{909E8E84-426E-40DD-AFC4-6F175D3DCCD1}">
+                <a14:hiddenFill xmlns:a14="http://schemas.microsoft.com/office/drawing/2010/main">
+                  <a:solidFill>
+                    <a:srgbClr val="FFFFFF"/>
+                  </a:solidFill>
+                </a14:hiddenFill>
+              </a:ext>
+            </a:extLst>
+          </p:spPr>
+          <p:txBody>
+            <a:bodyPr/>
+            <a:lstStyle/>
+            <a:p>
+              <a:endParaRPr lang="en-US"/>
+            </a:p>
+          </p:txBody>
+        </p:sp>
+        <p:sp>
+          <p:nvSpPr>
+            <p:cNvPr id="51" name="Freeform 21">
+              <a:extLst>
+                <a:ext uri="{FF2B5EF4-FFF2-40B4-BE49-F238E27FC236}">
+                  <a16:creationId xmlns:a16="http://schemas.microsoft.com/office/drawing/2014/main" id="{97B9FFE1-BC8C-4C55-AE5D-8FDD7800184A}"/>
+                </a:ext>
+                <a:ext uri="{C183D7F6-B498-43B3-948B-1728B52AA6E4}">
+                  <adec:decorative xmlns:adec="http://schemas.microsoft.com/office/drawing/2017/decorative" val="1"/>
+                </a:ext>
+              </a:extLst>
+            </p:cNvPr>
+            <p:cNvSpPr/>
+            <p:nvPr>
+              <p:extLst>
+                <p:ext uri="{386F3935-93C4-4BCD-93E2-E3B085C9AB24}">
+                  <p16:designElem xmlns:p16="http://schemas.microsoft.com/office/powerpoint/2015/main" val="1"/>
+                </p:ext>
+              </p:extLst>
+            </p:nvPr>
+          </p:nvSpPr>
+          <p:spPr bwMode="auto">
+            <a:xfrm>
+              <a:off x="261938" y="0"/>
+              <a:ext cx="2944813" cy="6843713"/>
+            </a:xfrm>
+            <a:custGeom>
+              <a:avLst/>
+              <a:gdLst/>
+              <a:ahLst/>
+              <a:cxnLst/>
+              <a:rect l="0" t="0" r="r" b="b"/>
+              <a:pathLst>
+                <a:path w="620" h="1440">
+                  <a:moveTo>
+                    <a:pt x="620" y="0"/>
+                  </a:moveTo>
+                  <a:cubicBezTo>
+                    <a:pt x="248" y="325"/>
+                    <a:pt x="0" y="960"/>
+                    <a:pt x="186" y="1440"/>
+                  </a:cubicBezTo>
+                </a:path>
+              </a:pathLst>
+            </a:custGeom>
+            <a:noFill/>
+            <a:ln w="9525" cap="flat">
+              <a:solidFill>
+                <a:schemeClr val="tx1">
+                  <a:alpha val="20000"/>
+                </a:schemeClr>
+              </a:solidFill>
+              <a:prstDash val="lgDash"/>
+              <a:miter lim="800000"/>
+              <a:headEnd/>
+              <a:tailEnd/>
+            </a:ln>
+            <a:extLst>
+              <a:ext uri="{909E8E84-426E-40DD-AFC4-6F175D3DCCD1}">
+                <a14:hiddenFill xmlns:a14="http://schemas.microsoft.com/office/drawing/2010/main">
+                  <a:solidFill>
+                    <a:srgbClr val="FFFFFF"/>
+                  </a:solidFill>
+                </a14:hiddenFill>
+              </a:ext>
+            </a:extLst>
+          </p:spPr>
+          <p:txBody>
+            <a:bodyPr/>
+            <a:lstStyle/>
+            <a:p>
+              <a:endParaRPr lang="en-US"/>
+            </a:p>
+          </p:txBody>
+        </p:sp>
+        <p:sp>
+          <p:nvSpPr>
+            <p:cNvPr id="52" name="Freeform 22">
+              <a:extLst>
+                <a:ext uri="{FF2B5EF4-FFF2-40B4-BE49-F238E27FC236}">
+                  <a16:creationId xmlns:a16="http://schemas.microsoft.com/office/drawing/2014/main" id="{6F87417E-9520-42E0-84D2-0C0225481A45}"/>
+                </a:ext>
+                <a:ext uri="{C183D7F6-B498-43B3-948B-1728B52AA6E4}">
+                  <adec:decorative xmlns:adec="http://schemas.microsoft.com/office/drawing/2017/decorative" val="1"/>
+                </a:ext>
+              </a:extLst>
+            </p:cNvPr>
+            <p:cNvSpPr/>
+            <p:nvPr>
+              <p:extLst>
+                <p:ext uri="{386F3935-93C4-4BCD-93E2-E3B085C9AB24}">
+                  <p16:designElem xmlns:p16="http://schemas.microsoft.com/office/powerpoint/2015/main" val="1"/>
+                </p:ext>
+              </p:extLst>
+            </p:nvPr>
+          </p:nvSpPr>
+          <p:spPr bwMode="auto">
+            <a:xfrm>
+              <a:off x="-417513" y="0"/>
+              <a:ext cx="2403475" cy="6843713"/>
+            </a:xfrm>
+            <a:custGeom>
+              <a:avLst/>
+              <a:gdLst/>
+              <a:ahLst/>
+              <a:cxnLst/>
+              <a:rect l="0" t="0" r="r" b="b"/>
+              <a:pathLst>
+                <a:path w="506" h="1440">
+                  <a:moveTo>
+                    <a:pt x="506" y="0"/>
+                  </a:moveTo>
+                  <a:cubicBezTo>
+                    <a:pt x="109" y="356"/>
+                    <a:pt x="0" y="943"/>
+                    <a:pt x="171" y="1440"/>
+                  </a:cubicBezTo>
+                </a:path>
+              </a:pathLst>
+            </a:custGeom>
+            <a:noFill/>
+            <a:ln w="9525" cap="flat">
+              <a:solidFill>
+                <a:schemeClr val="tx1">
+                  <a:alpha val="20000"/>
+                </a:schemeClr>
+              </a:solidFill>
+              <a:prstDash val="solid"/>
+              <a:miter lim="800000"/>
+              <a:headEnd/>
+              <a:tailEnd/>
+            </a:ln>
+            <a:extLst>
+              <a:ext uri="{909E8E84-426E-40DD-AFC4-6F175D3DCCD1}">
+                <a14:hiddenFill xmlns:a14="http://schemas.microsoft.com/office/drawing/2010/main">
+                  <a:solidFill>
+                    <a:srgbClr val="FFFFFF"/>
+                  </a:solidFill>
+                </a14:hiddenFill>
+              </a:ext>
+            </a:extLst>
+          </p:spPr>
+          <p:txBody>
+            <a:bodyPr/>
+            <a:lstStyle/>
+            <a:p>
+              <a:endParaRPr lang="en-US"/>
+            </a:p>
+          </p:txBody>
+        </p:sp>
+        <p:sp>
+          <p:nvSpPr>
+            <p:cNvPr id="53" name="Freeform 23">
+              <a:extLst>
+                <a:ext uri="{FF2B5EF4-FFF2-40B4-BE49-F238E27FC236}">
+                  <a16:creationId xmlns:a16="http://schemas.microsoft.com/office/drawing/2014/main" id="{1235F6B6-5324-426D-84BE-EF96FD4303DE}"/>
+                </a:ext>
+                <a:ext uri="{C183D7F6-B498-43B3-948B-1728B52AA6E4}">
+                  <adec:decorative xmlns:adec="http://schemas.microsoft.com/office/drawing/2017/decorative" val="1"/>
+                </a:ext>
+              </a:extLst>
+            </p:cNvPr>
+            <p:cNvSpPr/>
+            <p:nvPr>
+              <p:extLst>
+                <p:ext uri="{386F3935-93C4-4BCD-93E2-E3B085C9AB24}">
+                  <p16:designElem xmlns:p16="http://schemas.microsoft.com/office/powerpoint/2015/main" val="1"/>
+                </p:ext>
+              </p:extLst>
+            </p:nvPr>
+          </p:nvSpPr>
+          <p:spPr bwMode="auto">
+            <a:xfrm>
+              <a:off x="14288" y="9525"/>
+              <a:ext cx="1771650" cy="3198813"/>
+            </a:xfrm>
+            <a:custGeom>
+              <a:avLst/>
+              <a:gdLst/>
+              <a:ahLst/>
+              <a:cxnLst/>
+              <a:rect l="0" t="0" r="r" b="b"/>
+              <a:pathLst>
+                <a:path w="373" h="673">
+                  <a:moveTo>
+                    <a:pt x="373" y="0"/>
+                  </a:moveTo>
+                  <a:cubicBezTo>
+                    <a:pt x="175" y="183"/>
+                    <a:pt x="51" y="409"/>
+                    <a:pt x="0" y="673"/>
+                  </a:cubicBezTo>
+                </a:path>
+              </a:pathLst>
+            </a:custGeom>
+            <a:noFill/>
+            <a:ln w="9525" cap="flat">
+              <a:solidFill>
+                <a:schemeClr val="tx1">
+                  <a:alpha val="20000"/>
+                </a:schemeClr>
+              </a:solidFill>
+              <a:prstDash val="solid"/>
+              <a:miter lim="800000"/>
+              <a:headEnd/>
+              <a:tailEnd/>
+            </a:ln>
+            <a:extLst>
+              <a:ext uri="{909E8E84-426E-40DD-AFC4-6F175D3DCCD1}">
+                <a14:hiddenFill xmlns:a14="http://schemas.microsoft.com/office/drawing/2010/main">
+                  <a:solidFill>
+                    <a:srgbClr val="FFFFFF"/>
+                  </a:solidFill>
+                </a14:hiddenFill>
+              </a:ext>
+            </a:extLst>
+          </p:spPr>
+          <p:txBody>
+            <a:bodyPr/>
+            <a:lstStyle/>
+            <a:p>
+              <a:endParaRPr lang="en-US"/>
+            </a:p>
+          </p:txBody>
+        </p:sp>
+        <p:sp>
+          <p:nvSpPr>
+            <p:cNvPr id="54" name="Freeform 24">
+              <a:extLst>
+                <a:ext uri="{FF2B5EF4-FFF2-40B4-BE49-F238E27FC236}">
+                  <a16:creationId xmlns:a16="http://schemas.microsoft.com/office/drawing/2014/main" id="{093C61D3-C80D-4599-8280-763868B24201}"/>
+                </a:ext>
+                <a:ext uri="{C183D7F6-B498-43B3-948B-1728B52AA6E4}">
+                  <adec:decorative xmlns:adec="http://schemas.microsoft.com/office/drawing/2017/decorative" val="1"/>
+                </a:ext>
+              </a:extLst>
+            </p:cNvPr>
+            <p:cNvSpPr/>
+            <p:nvPr>
+              <p:extLst>
+                <p:ext uri="{386F3935-93C4-4BCD-93E2-E3B085C9AB24}">
+                  <p16:designElem xmlns:p16="http://schemas.microsoft.com/office/powerpoint/2015/main" val="1"/>
+                </p:ext>
+              </p:extLst>
+            </p:nvPr>
+          </p:nvSpPr>
+          <p:spPr bwMode="auto">
+            <a:xfrm>
+              <a:off x="4763" y="6016625"/>
+              <a:ext cx="214313" cy="827088"/>
+            </a:xfrm>
+            <a:custGeom>
+              <a:avLst/>
+              <a:gdLst/>
+              <a:ahLst/>
+              <a:cxnLst/>
+              <a:rect l="0" t="0" r="r" b="b"/>
+              <a:pathLst>
+                <a:path w="45" h="174">
+                  <a:moveTo>
+                    <a:pt x="0" y="0"/>
+                  </a:moveTo>
+                  <a:cubicBezTo>
+                    <a:pt x="11" y="59"/>
+                    <a:pt x="26" y="118"/>
+                    <a:pt x="45" y="174"/>
+                  </a:cubicBezTo>
+                </a:path>
+              </a:pathLst>
+            </a:custGeom>
+            <a:noFill/>
+            <a:ln w="9525" cap="flat">
+              <a:solidFill>
+                <a:schemeClr val="tx1">
+                  <a:alpha val="20000"/>
+                </a:schemeClr>
+              </a:solidFill>
+              <a:prstDash val="solid"/>
+              <a:miter lim="800000"/>
+              <a:headEnd/>
+              <a:tailEnd/>
+            </a:ln>
+            <a:extLst>
+              <a:ext uri="{909E8E84-426E-40DD-AFC4-6F175D3DCCD1}">
+                <a14:hiddenFill xmlns:a14="http://schemas.microsoft.com/office/drawing/2010/main">
+                  <a:solidFill>
+                    <a:srgbClr val="FFFFFF"/>
+                  </a:solidFill>
+                </a14:hiddenFill>
+              </a:ext>
+            </a:extLst>
+          </p:spPr>
+          <p:txBody>
+            <a:bodyPr/>
+            <a:lstStyle/>
+            <a:p>
+              <a:endParaRPr lang="en-US"/>
+            </a:p>
+          </p:txBody>
+        </p:sp>
+        <p:sp>
+          <p:nvSpPr>
+            <p:cNvPr id="55" name="Freeform 25">
+              <a:extLst>
+                <a:ext uri="{FF2B5EF4-FFF2-40B4-BE49-F238E27FC236}">
+                  <a16:creationId xmlns:a16="http://schemas.microsoft.com/office/drawing/2014/main" id="{D6D942F2-89B9-4755-89D9-4365831760B9}"/>
+                </a:ext>
+                <a:ext uri="{C183D7F6-B498-43B3-948B-1728B52AA6E4}">
+                  <adec:decorative xmlns:adec="http://schemas.microsoft.com/office/drawing/2017/decorative" val="1"/>
+                </a:ext>
+              </a:extLst>
+            </p:cNvPr>
+            <p:cNvSpPr/>
+            <p:nvPr>
+              <p:extLst>
+                <p:ext uri="{386F3935-93C4-4BCD-93E2-E3B085C9AB24}">
+                  <p16:designElem xmlns:p16="http://schemas.microsoft.com/office/powerpoint/2015/main" val="1"/>
+                </p:ext>
+              </p:extLst>
+            </p:nvPr>
+          </p:nvSpPr>
+          <p:spPr bwMode="auto">
+            <a:xfrm>
+              <a:off x="14288" y="0"/>
+              <a:ext cx="1562100" cy="2228850"/>
+            </a:xfrm>
+            <a:custGeom>
+              <a:avLst/>
+              <a:gdLst/>
+              <a:ahLst/>
+              <a:cxnLst/>
+              <a:rect l="0" t="0" r="r" b="b"/>
+              <a:pathLst>
+                <a:path w="329" h="469">
+                  <a:moveTo>
+                    <a:pt x="329" y="0"/>
+                  </a:moveTo>
+                  <a:cubicBezTo>
+                    <a:pt x="189" y="133"/>
+                    <a:pt x="69" y="288"/>
+                    <a:pt x="0" y="469"/>
+                  </a:cubicBezTo>
+                </a:path>
+              </a:pathLst>
+            </a:custGeom>
+            <a:noFill/>
+            <a:ln w="9525" cap="flat">
+              <a:solidFill>
+                <a:schemeClr val="tx1">
+                  <a:alpha val="20000"/>
+                </a:schemeClr>
+              </a:solidFill>
+              <a:prstDash val="solid"/>
+              <a:miter lim="800000"/>
+              <a:headEnd/>
+              <a:tailEnd/>
+            </a:ln>
+            <a:extLst>
+              <a:ext uri="{909E8E84-426E-40DD-AFC4-6F175D3DCCD1}">
+                <a14:hiddenFill xmlns:a14="http://schemas.microsoft.com/office/drawing/2010/main">
+                  <a:solidFill>
+                    <a:srgbClr val="FFFFFF"/>
+                  </a:solidFill>
+                </a14:hiddenFill>
+              </a:ext>
+            </a:extLst>
+          </p:spPr>
+          <p:txBody>
+            <a:bodyPr/>
+            <a:lstStyle/>
+            <a:p>
+              <a:endParaRPr lang="en-US"/>
+            </a:p>
+          </p:txBody>
+        </p:sp>
+      </p:grpSp>
+      <p:sp>
+        <p:nvSpPr>
+          <p:cNvPr id="56" name="Rectangle 55">
+            <a:extLst>
+              <a:ext uri="{FF2B5EF4-FFF2-40B4-BE49-F238E27FC236}">
+                <a16:creationId xmlns:a16="http://schemas.microsoft.com/office/drawing/2014/main" id="{C40B6375-7479-45C4-8B99-EA1CF75F31E2}"/>
+              </a:ext>
+              <a:ext uri="{C183D7F6-B498-43B3-948B-1728B52AA6E4}">
+                <adec:decorative xmlns:adec="http://schemas.microsoft.com/office/drawing/2017/decorative" val="1"/>
+              </a:ext>
+            </a:extLst>
+          </p:cNvPr>
+          <p:cNvSpPr>
+            <a:spLocks noGrp="1" noRot="1" noChangeAspect="1" noMove="1" noResize="1" noEditPoints="1" noAdjustHandles="1" noChangeArrowheads="1" noChangeShapeType="1" noTextEdit="1"/>
+          </p:cNvSpPr>
+          <p:nvPr>
+            <p:extLst>
+              <p:ext uri="{386F3935-93C4-4BCD-93E2-E3B085C9AB24}">
+                <p16:designElem xmlns:p16="http://schemas.microsoft.com/office/powerpoint/2015/main" val="1"/>
+              </p:ext>
+            </p:extLst>
+          </p:nvPr>
+        </p:nvSpPr>
+        <p:spPr>
+          <a:xfrm>
+            <a:off x="477012" y="480060"/>
+            <a:ext cx="11237976" cy="5897880"/>
+          </a:xfrm>
+          <a:prstGeom prst="rect">
+            <a:avLst/>
+          </a:prstGeom>
+          <a:solidFill>
+            <a:srgbClr val="FFFFFF"/>
+          </a:solidFill>
+          <a:ln w="22225">
+            <a:solidFill>
+              <a:srgbClr val="FBAC15"/>
+            </a:solidFill>
+          </a:ln>
+          <a:effectLst>
+            <a:outerShdw blurRad="76200" algn="ctr" rotWithShape="0">
+              <a:prstClr val="black">
+                <a:alpha val="20000"/>
+              </a:prstClr>
+            </a:outerShdw>
+          </a:effectLst>
+        </p:spPr>
+        <p:style>
+          <a:lnRef idx="2">
+            <a:schemeClr val="accent1">
+              <a:shade val="50000"/>
+            </a:schemeClr>
+          </a:lnRef>
+          <a:fillRef idx="1">
+            <a:schemeClr val="accent1"/>
+          </a:fillRef>
+          <a:effectRef idx="0">
+            <a:schemeClr val="accent1"/>
+          </a:effectRef>
+          <a:fontRef idx="minor">
+            <a:schemeClr val="lt1"/>
+          </a:fontRef>
+        </p:style>
+        <p:txBody>
+          <a:bodyPr rtlCol="0" anchor="ctr"/>
+          <a:lstStyle/>
+          <a:p>
+            <a:pPr algn="ctr"/>
+            <a:endParaRPr lang="en-US"/>
+          </a:p>
+        </p:txBody>
+      </p:sp>
+      <p:pic>
+        <p:nvPicPr>
+          <p:cNvPr id="3" name="Picture 2">
+            <a:extLst>
+              <a:ext uri="{FF2B5EF4-FFF2-40B4-BE49-F238E27FC236}">
+                <a16:creationId xmlns:a16="http://schemas.microsoft.com/office/drawing/2014/main" id="{25B4F8F0-FDCC-2BD4-C2FA-32ADB06A9822}"/>
+              </a:ext>
+            </a:extLst>
+          </p:cNvPr>
+          <p:cNvPicPr>
+            <a:picLocks noChangeAspect="1"/>
+          </p:cNvPicPr>
+          <p:nvPr/>
+        </p:nvPicPr>
+        <p:blipFill>
+          <a:blip r:embed="rId2">
+            <a:extLst>
+              <a:ext uri="{28A0092B-C50C-407E-A947-70E740481C1C}">
+                <a14:useLocalDpi xmlns:a14="http://schemas.microsoft.com/office/drawing/2010/main" val="0"/>
+              </a:ext>
+            </a:extLst>
+          </a:blip>
+          <a:stretch>
+            <a:fillRect/>
+          </a:stretch>
+        </p:blipFill>
+        <p:spPr>
+          <a:xfrm>
+            <a:off x="913613" y="643467"/>
+            <a:ext cx="10364774" cy="5571066"/>
+          </a:xfrm>
+          <a:prstGeom prst="rect">
+            <a:avLst/>
+          </a:prstGeom>
+        </p:spPr>
+      </p:pic>
+    </p:spTree>
+    <p:extLst>
+      <p:ext uri="{BB962C8B-B14F-4D97-AF65-F5344CB8AC3E}">
+        <p14:creationId xmlns:p14="http://schemas.microsoft.com/office/powerpoint/2010/main" val="4194424191"/>
+      </p:ext>
+    </p:extLst>
+  </p:cSld>
+  <p:clrMapOvr>
+    <a:masterClrMapping/>
+  </p:clrMapOvr>
+  <mc:AlternateContent xmlns:mc="http://schemas.openxmlformats.org/markup-compatibility/2006" xmlns:p14="http://schemas.microsoft.com/office/powerpoint/2010/main">
+    <mc:Choice Requires="p14">
+      <p:transition spd="med" p14:dur="700">
+        <p:fade/>
+      </p:transition>
+    </mc:Choice>
+    <mc:Fallback xmlns="">
+      <p:transition spd="med">
+        <p:fade/>
+      </p:transition>
+    </mc:Fallback>
+  </mc:AlternateContent>
+</p:sld>
+</file>
+
+<file path=ppt/slides/slide5.xml><?xml version="1.0" encoding="utf-8"?>
+<p:sld xmlns:a="http://schemas.openxmlformats.org/drawingml/2006/main" xmlns:r="http://schemas.openxmlformats.org/officeDocument/2006/relationships" xmlns:p="http://schemas.openxmlformats.org/presentationml/2006/main">
+  <p:cSld>
+    <p:bg>
+      <p:bgPr>
+        <a:solidFill>
           <a:schemeClr val="bg1"/>
         </a:solidFill>
         <a:effectLst/>
@@ -31828,7 +33594,7 @@
 </p:sld>
 </file>
 
-<file path=ppt/slides/slide5.xml><?xml version="1.0" encoding="utf-8"?>
+<file path=ppt/slides/slide6.xml><?xml version="1.0" encoding="utf-8"?>
 <p:sld xmlns:a="http://schemas.openxmlformats.org/drawingml/2006/main" xmlns:r="http://schemas.openxmlformats.org/officeDocument/2006/relationships" xmlns:p="http://schemas.openxmlformats.org/presentationml/2006/main">
   <p:cSld>
     <p:bg>
@@ -34247,7 +36013,7 @@
 </p:sld>
 </file>
 
-<file path=ppt/slides/slide6.xml><?xml version="1.0" encoding="utf-8"?>
+<file path=ppt/slides/slide7.xml><?xml version="1.0" encoding="utf-8"?>
 <p:sld xmlns:a="http://schemas.openxmlformats.org/drawingml/2006/main" xmlns:r="http://schemas.openxmlformats.org/officeDocument/2006/relationships" xmlns:p="http://schemas.openxmlformats.org/presentationml/2006/main">
   <p:cSld>
     <p:bg>

</xml_diff>